<commit_message>
Form 3 L23-L42: revise to the validated model; shrink long board-summary cover text
Coasts, deserts, atmosphere, weather and climate follow the syllabus
headings point by point (thermal structure, monsoon, isolines, siting of
the Stevenson screen...). The board-summary cover uses 32 pt when the topic,
sub-topic and lesson names are long, so it no longer runs into the footer;
Form 1 and Form 2 are rebuilt with this fix.

Co-Authored-By: Claude Opus 5.5 <noreply@anthropic.com>
Claude-Session: https://claude.ai/code/session_0115LFSb2ktGLWPeVksFkSer
</commit_message>
<xml_diff>
--- a/lecons/F1/01_F1_M1_L01_Geography_Meaning_Branches_Methods_and_Importance.pptx
+++ b/lecons/F1/01_F1_M1_L01_Geography_Meaning_Branches_Methods_and_Importance.pptx
@@ -13777,7 +13777,7 @@
               <a:buNone/>
             </a:pPr>
             <a:r>
-              <a:rPr lang="en-US" sz="4000" b="1" dirty="0">
+              <a:rPr lang="en-US" sz="3200" b="1" dirty="0">
                 <a:solidFill>
                   <a:srgbClr val="111111"/>
                 </a:solidFill>
@@ -13787,7 +13787,7 @@
               </a:rPr>
               <a:t>Topic: The Earth in the Universe</a:t>
             </a:r>
-            <a:endParaRPr lang="en-US" sz="4000" dirty="0"/>
+            <a:endParaRPr lang="en-US" sz="3200" dirty="0"/>
           </a:p>
           <a:p>
             <a:pPr algn="l" indent="0" marL="0">
@@ -13797,7 +13797,7 @@
               <a:buNone/>
             </a:pPr>
             <a:r>
-              <a:rPr lang="en-US" sz="4000" b="1" dirty="0">
+              <a:rPr lang="en-US" sz="3200" b="1" dirty="0">
                 <a:solidFill>
                   <a:srgbClr val="111111"/>
                 </a:solidFill>
@@ -13807,7 +13807,7 @@
               </a:rPr>
               <a:t>Sub-topic: Introduction to Geography</a:t>
             </a:r>
-            <a:endParaRPr lang="en-US" sz="4000" dirty="0"/>
+            <a:endParaRPr lang="en-US" sz="3200" dirty="0"/>
           </a:p>
           <a:p>
             <a:pPr algn="l" indent="0" marL="0">
@@ -13817,7 +13817,7 @@
               <a:buNone/>
             </a:pPr>
             <a:r>
-              <a:rPr lang="en-US" sz="4000" b="1" dirty="0">
+              <a:rPr lang="en-US" sz="3200" b="1" dirty="0">
                 <a:solidFill>
                   <a:srgbClr val="990011"/>
                 </a:solidFill>
@@ -13827,7 +13827,7 @@
               </a:rPr>
               <a:t>Lesson 1: Geography: Meaning, Branches, Methods and Importance</a:t>
             </a:r>
-            <a:endParaRPr lang="en-US" sz="4000" dirty="0"/>
+            <a:endParaRPr lang="en-US" sz="3200" dirty="0"/>
           </a:p>
         </p:txBody>
       </p:sp>

</xml_diff>

<commit_message>
First cycle: short homework preparing the next lesson (F1, F2, F3, F2T)
Each homework is now one short sentence on a small part of the next lesson,
with its answer corrected at the start of that lesson (sources/f4/v3/homework.js).

Co-Authored-By: Claude Opus 5.5 <noreply@anthropic.com>
Claude-Session: https://claude.ai/code/session_0115LFSb2ktGLWPeVksFkSer
</commit_message>
<xml_diff>
--- a/lecons/F1/01_F1_M1_L01_Geography_Meaning_Branches_Methods_and_Importance.pptx
+++ b/lecons/F1/01_F1_M1_L01_Geography_Meaning_Branches_Methods_and_Importance.pptx
@@ -4606,7 +4606,7 @@
           <a:p>
             <a:r>
               <a:rPr lang="en-US" dirty="0"/>
-              <a:t>For your homework: Write three physical features and three human activities that you see on your way to school. We shall correct it at the beginning of our next lesson.</a:t>
+              <a:t>For your homework: Name the eight planets of the solar system. We shall correct it at the beginning of our next lesson.</a:t>
             </a:r>
             <a:endParaRPr lang="en-US" dirty="0"/>
           </a:p>
@@ -18800,7 +18800,7 @@
                 <a:ea typeface="Times New Roman" pitchFamily="34" charset="-122"/>
                 <a:cs typeface="Times New Roman" pitchFamily="34" charset="-120"/>
               </a:rPr>
-              <a:t>Write three physical features and three human activities that you see on your way to school.</a:t>
+              <a:t>Name the eight planets of the solar system.</a:t>
             </a:r>
             <a:endParaRPr lang="en-US" sz="4000" dirty="0"/>
           </a:p>
@@ -21464,7 +21464,7 @@
                           <a:ea typeface="Calibri" pitchFamily="34" charset="-122"/>
                           <a:cs typeface="Calibri" pitchFamily="34" charset="-120"/>
                         </a:rPr>
-                        <a:t>Write three physical features and three human activities that you see on your way to school.</a:t>
+                        <a:t>Name the eight planets of the solar system.</a:t>
                       </a:r>
                       <a:endParaRPr lang="en-US" sz="1600" dirty="0">
                         <a:latin typeface="Calibri" charset="0"/>

</xml_diff>